<commit_message>
Add streaming ladder algorithms and update references
- Introduced a new section on the relaxation ladder for streaming and offline algorithms in Appendix A.7, detailing the models and algorithms used.
- Updated the code execution instructions to include new scripts for running and plotting the streaming ladder results.
- Added references for semi-streaming matching algorithms to the bibliography.
- Updated the word count in the LaTeX document.
- Made minor adjustments to the Chinese background and conclusion sections for clarity and coherence.
</commit_message>
<xml_diff>
--- a/thesis/defence/defence.pptx
+++ b/thesis/defence/defence.pptx
@@ -20,9 +20,10 @@
     <p:sldId id="268" r:id="rId14"/>
     <p:sldId id="269" r:id="rId15"/>
     <p:sldId id="270" r:id="rId16"/>
+    <p:sldId id="271" r:id="rId17"/>
   </p:sldIdLst>
   <p:notesMasterIdLst>
-    <p:notesMasterId r:id="rId17"/>
+    <p:notesMasterId r:id="rId18"/>
   </p:notesMasterIdLst>
   <p:sldSz cx="12192000" cy="6858000"/>
   <p:notesSz cx="6858000" cy="12192000"/>
@@ -790,12 +791,10 @@
           <a:p>
             <a:r>
               <a:rPr lang="en-US" dirty="0"/>
-              <a:t>Let me be explicit about how far the project got against its own objectives.
-Q1 is met in full. Q2 is met with one qualification I would rather state than have you find: the test I measured is the surrogate the original authors specify, not an implemented tolerant tester. So these are strictly the failure modes of the mechanism as published.
-Q3 is the one the thesis falls furthest short of — bracketed, not closed.
-Four judgements with hindsight. The structured error models were the best decision in the project; independent noise would have averaged away the order effect entirely.
-Two are debatable. Known-i.i.d. is right for comparability, but it is also the model where the baseline is strongest, so the choice partly pre-selected my headline finding. And measuring only matching size is what most limits the conclusion's reach — a second objective should have run through the whole benchmark rather than arriving as a late probe.
-And a process lesson: I ran the synthetic stages before the real-feature test, when the real-feature test is both cheaper and decisive.</a:t>
+              <a:t>Let me be explicit about how far the project got against its own aims, because I think that is the fair way to be examined.
+The brief I was given asked me to reproduce some of Borodin et al.'s experiments, extend them with additional algorithms, and compare on different graph types. The reproduction and the graph types are done. The extension is done but not in the direction the brief suggested — it named streaming or offline algorithms, and my proposal substituted the learning-augmented family, on the argument that its theory had outrun its experiments. I raised that with my supervisor before starting and I would defend it, but it is a substitution rather than an addition.
+Against my own proposal: RQ1, whether the theoretical ordering matches the practical one, is answered, and the answer is no — the worst-case-designed algorithms are the weakest advice-free entries here. RQ3, the real cost of the fallback mechanism, is answered most completely. RQ2, the shape of the error curves and where they cross, only in part.
+And one thing I promised and did not deliver. My proposal made arrival order an independent variable, to be reported separately for random, adversarial and real order. I worked only in known-i.i.d. Real order appears through the traces, but there is no adversarial arm — and known-i.i.d. is exactly the model where my headline is most likely to hold. That removed the one condition that could have falsified it, which is why it heads the future work.</a:t>
             </a:r>
             <a:endParaRPr lang="en-US" dirty="0"/>
           </a:p>
@@ -1065,9 +1064,7 @@
           <a:p>
             <a:r>
               <a:rPr lang="en-US" dirty="0"/>
-              <a:t>Backup slide: the limitations, as stated in the thesis.
-The two I would volunteer first if asked what most constrains the conclusion are the input model and the objective. The wall is an average-case statement in the known-i.i.d. model, and it is a statement about matching size. Both are named in the future work as exactly where a positive counterpart should be looked for.
-On the test model: the surrogate is what the original authors specify, and section 10.2 argues its blindness is structural rather than an implementation artefact — but that argument is an interpretation of measurements, not a measurement of an actual tolerant tester.</a:t>
+              <a:t>Backup slide: the relaxation ladder, Appendix A.7. This is the arm the brief actually suggested — streaming or offline algorithms — done at reduced scope after the main work, and arranged so it speaks to my own question rather than sitting beside it. Semi-streaming means the graph arrives as a stream of edges, memory is O(n), and you may take several passes; so relative to online vertex arrival it takes memory away and gives revision back. Two things came out. First, one pass is not a free lunch: it is worse than online Greedy on seven of the nine graphs, because vertex arrival groups a node's edges together and a random edge order does not. Second, the second pass is the lever — one revision pass buys more than a perfect degree prediction on seven of nine, including every real graph. That locates the residual gap in irrevocability rather than in missing information, which is the same conclusion Chapter 6 reaches from the other side. The honest caveat is that a second pass is not an online algorithm at all: where the decision is physically committed on arrival, prediction is the only one of the two routes available. The ladder measures the size of each route's upside, not its applicability.</a:t>
             </a:r>
             <a:endParaRPr lang="en-US" dirty="0"/>
           </a:p>
@@ -1091,6 +1088,96 @@
             <a:fld id="{F7021451-1387-4CA6-816F-3879F97B5CBC}" type="slidenum">
               <a:rPr lang="en-US"/>
               <a:t>15</a:t>
+            </a:fld>
+            <a:endParaRPr lang="en-US"/>
+          </a:p>
+        </p:txBody>
+      </p:sp>
+    </p:spTree>
+    <p:extLst>
+      <p:ext uri="{BB962C8B-B14F-4D97-AF65-F5344CB8AC3E}">
+        <p14:creationId xmlns:p14="http://schemas.microsoft.com/office/powerpoint/2010/main" val="1024086991"/>
+      </p:ext>
+    </p:extLst>
+  </p:cSld>
+  <p:clrMapOvr>
+    <a:masterClrMapping/>
+  </p:clrMapOvr>
+</p:notes>
+</file>
+
+<file path=ppt/notesSlides/notesSlide16.xml><?xml version="1.0" encoding="utf-8"?>
+<p:notes xmlns:a="http://schemas.openxmlformats.org/drawingml/2006/main" xmlns:r="http://schemas.openxmlformats.org/officeDocument/2006/relationships" xmlns:p="http://schemas.openxmlformats.org/presentationml/2006/main">
+  <p:cSld>
+    <p:spTree>
+      <p:nvGrpSpPr>
+        <p:cNvPr id="1" name=""/>
+        <p:cNvGrpSpPr/>
+        <p:nvPr/>
+      </p:nvGrpSpPr>
+      <p:grpSpPr>
+        <a:xfrm>
+          <a:off x="0" y="0"/>
+          <a:ext cx="0" cy="0"/>
+          <a:chOff x="0" y="0"/>
+          <a:chExt cx="0" cy="0"/>
+        </a:xfrm>
+      </p:grpSpPr>
+      <p:sp>
+        <p:nvSpPr>
+          <p:cNvPr id="2" name="Slide Image Placeholder 1"/>
+          <p:cNvSpPr>
+            <a:spLocks noGrp="1" noRot="1" noChangeAspect="1"/>
+          </p:cNvSpPr>
+          <p:nvPr>
+            <p:ph type="sldImg"/>
+          </p:nvPr>
+        </p:nvSpPr>
+        <p:spPr/>
+      </p:sp>
+      <p:sp>
+        <p:nvSpPr>
+          <p:cNvPr id="3" name="Notes Placeholder 2"/>
+          <p:cNvSpPr>
+            <a:spLocks noGrp="1"/>
+          </p:cNvSpPr>
+          <p:nvPr>
+            <p:ph type="body" idx="1"/>
+          </p:nvPr>
+        </p:nvSpPr>
+        <p:spPr/>
+        <p:txBody>
+          <a:bodyPr/>
+          <a:lstStyle/>
+          <a:p>
+            <a:r>
+              <a:rPr lang="en-US" dirty="0"/>
+              <a:t>Backup slide: the limitations, as stated in the thesis.
+The two I would volunteer first if asked what most constrains the conclusion are the input model and the objective. The wall is an average-case statement in the known-i.i.d. model, and it is a statement about matching size. Both are named in the future work as exactly where a positive counterpart should be looked for.
+On the test model: the surrogate is what the original authors specify, and section 10.2 argues its blindness is structural rather than an implementation artefact — but that argument is an interpretation of measurements, not a measurement of an actual tolerant tester.</a:t>
+            </a:r>
+            <a:endParaRPr lang="en-US" dirty="0"/>
+          </a:p>
+        </p:txBody>
+      </p:sp>
+      <p:sp>
+        <p:nvSpPr>
+          <p:cNvPr id="4" name="Slide Number Placeholder 3"/>
+          <p:cNvSpPr>
+            <a:spLocks noGrp="1"/>
+          </p:cNvSpPr>
+          <p:nvPr>
+            <p:ph type="sldNum" sz="quarter" idx="10"/>
+          </p:nvPr>
+        </p:nvSpPr>
+        <p:spPr/>
+        <p:txBody>
+          <a:bodyPr/>
+          <a:lstStyle/>
+          <a:p>
+            <a:fld id="{F7021451-1387-4CA6-816F-3879F97B5CBC}" type="slidenum">
+              <a:rPr lang="en-US"/>
+              <a:t>16</a:t>
             </a:fld>
             <a:endParaRPr lang="en-US"/>
           </a:p>
@@ -4054,12 +4141,12 @@
         </p:nvSpPr>
         <p:spPr>
           <a:xfrm>
-            <a:off x="640080" y="1691640"/>
-            <a:ext cx="5577840" cy="1280160"/>
+            <a:off x="640080" y="1645920"/>
+            <a:ext cx="5577840" cy="1024128"/>
           </a:xfrm>
           <a:prstGeom prst="roundRect">
             <a:avLst>
-              <a:gd name="adj" fmla="val 5714"/>
+              <a:gd name="adj" fmla="val 7143"/>
             </a:avLst>
           </a:prstGeom>
           <a:solidFill>
@@ -4081,14 +4168,14 @@
         </p:nvSpPr>
         <p:spPr>
           <a:xfrm>
-            <a:off x="914400" y="2103120"/>
+            <a:off x="914400" y="1929384"/>
             <a:ext cx="457200" cy="457200"/>
           </a:xfrm>
           <a:prstGeom prst="ellipse">
             <a:avLst/>
           </a:prstGeom>
           <a:solidFill>
-            <a:srgbClr val="2F6F6B"/>
+            <a:srgbClr val="C8A24B"/>
           </a:solidFill>
           <a:ln/>
         </p:spPr>
@@ -4101,7 +4188,7 @@
         </p:nvSpPr>
         <p:spPr>
           <a:xfrm>
-            <a:off x="914400" y="2103120"/>
+            <a:off x="914400" y="1929384"/>
             <a:ext cx="457200" cy="457200"/>
           </a:xfrm>
           <a:prstGeom prst="rect">
@@ -4140,24 +4227,24 @@
         </p:nvSpPr>
         <p:spPr>
           <a:xfrm>
-            <a:off x="1554480" y="1856232"/>
-            <a:ext cx="4480560" cy="320040"/>
-          </a:xfrm>
-          <a:prstGeom prst="rect">
-            <a:avLst/>
-          </a:prstGeom>
-          <a:noFill/>
-          <a:ln/>
-        </p:spPr>
-        <p:txBody>
-          <a:bodyPr wrap="square" lIns="0" tIns="0" rIns="0" bIns="0" rtlCol="0" anchor="ctr"/>
-          <a:lstStyle/>
-          <a:p>
-            <a:pPr indent="0" marL="0">
-              <a:buNone/>
-            </a:pPr>
-            <a:r>
-              <a:rPr lang="en-US" sz="1600" b="1" dirty="0">
+            <a:off x="1554480" y="1755648"/>
+            <a:ext cx="4480560" cy="292608"/>
+          </a:xfrm>
+          <a:prstGeom prst="rect">
+            <a:avLst/>
+          </a:prstGeom>
+          <a:noFill/>
+          <a:ln/>
+        </p:spPr>
+        <p:txBody>
+          <a:bodyPr wrap="square" lIns="0" tIns="0" rIns="0" bIns="0" rtlCol="0" anchor="ctr"/>
+          <a:lstStyle/>
+          <a:p>
+            <a:pPr indent="0" marL="0">
+              <a:buNone/>
+            </a:pPr>
+            <a:r>
+              <a:rPr lang="en-US" sz="1500" b="1" dirty="0">
                 <a:solidFill>
                   <a:srgbClr val="FFFFFF"/>
                 </a:solidFill>
@@ -4165,9 +4252,9 @@
                 <a:ea typeface="Cambria" pitchFamily="34" charset="-122"/>
                 <a:cs typeface="Cambria" pitchFamily="34" charset="-120"/>
               </a:rPr>
-              <a:t>Q1 — met in full</a:t>
-            </a:r>
-            <a:endParaRPr lang="en-US" sz="1600" dirty="0"/>
+              <a:t>The brief: met, with one substitution</a:t>
+            </a:r>
+            <a:endParaRPr lang="en-US" sz="1500" dirty="0"/>
           </a:p>
         </p:txBody>
       </p:sp>
@@ -4179,24 +4266,24 @@
         </p:nvSpPr>
         <p:spPr>
           <a:xfrm>
-            <a:off x="1554480" y="2221992"/>
-            <a:ext cx="4480560" cy="640080"/>
-          </a:xfrm>
-          <a:prstGeom prst="rect">
-            <a:avLst/>
-          </a:prstGeom>
-          <a:noFill/>
-          <a:ln/>
-        </p:spPr>
-        <p:txBody>
-          <a:bodyPr wrap="square" lIns="0" tIns="0" rIns="0" bIns="0" rtlCol="0" anchor="ctr"/>
-          <a:lstStyle/>
-          <a:p>
-            <a:pPr indent="0" marL="0">
-              <a:buNone/>
-            </a:pPr>
-            <a:r>
-              <a:rPr lang="en-US" sz="1200" dirty="0">
+            <a:off x="1554480" y="2066544"/>
+            <a:ext cx="4480560" cy="548640"/>
+          </a:xfrm>
+          <a:prstGeom prst="rect">
+            <a:avLst/>
+          </a:prstGeom>
+          <a:noFill/>
+          <a:ln/>
+        </p:spPr>
+        <p:txBody>
+          <a:bodyPr wrap="square" lIns="0" tIns="0" rIns="0" bIns="0" rtlCol="0" anchor="ctr"/>
+          <a:lstStyle/>
+          <a:p>
+            <a:pPr indent="0" marL="0">
+              <a:buNone/>
+            </a:pPr>
+            <a:r>
+              <a:rPr lang="en-US" sz="1150" dirty="0">
                 <a:solidFill>
                   <a:srgbClr val="DDE4EA"/>
                 </a:solidFill>
@@ -4204,9 +4291,9 @@
                 <a:ea typeface="Calibri" pitchFamily="34" charset="-122"/>
                 <a:cs typeface="Calibri" pitchFamily="34" charset="-120"/>
               </a:rPr>
-              <a:t>the benchmark answers it numerically, and it survives real predictors and real graphs</a:t>
-            </a:r>
-            <a:endParaRPr lang="en-US" sz="1200" dirty="0"/>
+              <a:t>reproduction and graph types as asked; the extension went to learning-augmented, not streaming — Appendix A.7 now adds that arm</a:t>
+            </a:r>
+            <a:endParaRPr lang="en-US" sz="1150" dirty="0"/>
           </a:p>
         </p:txBody>
       </p:sp>
@@ -4218,12 +4305,12 @@
         </p:nvSpPr>
         <p:spPr>
           <a:xfrm>
-            <a:off x="640080" y="3172968"/>
-            <a:ext cx="5577840" cy="1280160"/>
+            <a:off x="640080" y="2816352"/>
+            <a:ext cx="5577840" cy="1024128"/>
           </a:xfrm>
           <a:prstGeom prst="roundRect">
             <a:avLst>
-              <a:gd name="adj" fmla="val 5714"/>
+              <a:gd name="adj" fmla="val 7143"/>
             </a:avLst>
           </a:prstGeom>
           <a:solidFill>
@@ -4245,14 +4332,14 @@
         </p:nvSpPr>
         <p:spPr>
           <a:xfrm>
-            <a:off x="914400" y="3584448"/>
+            <a:off x="914400" y="3099816"/>
             <a:ext cx="457200" cy="457200"/>
           </a:xfrm>
           <a:prstGeom prst="ellipse">
             <a:avLst/>
           </a:prstGeom>
           <a:solidFill>
-            <a:srgbClr val="C8A24B"/>
+            <a:srgbClr val="2F6F6B"/>
           </a:solidFill>
           <a:ln/>
         </p:spPr>
@@ -4265,7 +4352,7 @@
         </p:nvSpPr>
         <p:spPr>
           <a:xfrm>
-            <a:off x="914400" y="3584448"/>
+            <a:off x="914400" y="3099816"/>
             <a:ext cx="457200" cy="457200"/>
           </a:xfrm>
           <a:prstGeom prst="rect">
@@ -4304,24 +4391,24 @@
         </p:nvSpPr>
         <p:spPr>
           <a:xfrm>
-            <a:off x="1554480" y="3337560"/>
-            <a:ext cx="4480560" cy="320040"/>
-          </a:xfrm>
-          <a:prstGeom prst="rect">
-            <a:avLst/>
-          </a:prstGeom>
-          <a:noFill/>
-          <a:ln/>
-        </p:spPr>
-        <p:txBody>
-          <a:bodyPr wrap="square" lIns="0" tIns="0" rIns="0" bIns="0" rtlCol="0" anchor="ctr"/>
-          <a:lstStyle/>
-          <a:p>
-            <a:pPr indent="0" marL="0">
-              <a:buNone/>
-            </a:pPr>
-            <a:r>
-              <a:rPr lang="en-US" sz="1600" b="1" dirty="0">
+            <a:off x="1554480" y="2926080"/>
+            <a:ext cx="4480560" cy="292608"/>
+          </a:xfrm>
+          <a:prstGeom prst="rect">
+            <a:avLst/>
+          </a:prstGeom>
+          <a:noFill/>
+          <a:ln/>
+        </p:spPr>
+        <p:txBody>
+          <a:bodyPr wrap="square" lIns="0" tIns="0" rIns="0" bIns="0" rtlCol="0" anchor="ctr"/>
+          <a:lstStyle/>
+          <a:p>
+            <a:pPr indent="0" marL="0">
+              <a:buNone/>
+            </a:pPr>
+            <a:r>
+              <a:rPr lang="en-US" sz="1500" b="1" dirty="0">
                 <a:solidFill>
                   <a:srgbClr val="FFFFFF"/>
                 </a:solidFill>
@@ -4329,9 +4416,9 @@
                 <a:ea typeface="Cambria" pitchFamily="34" charset="-122"/>
                 <a:cs typeface="Cambria" pitchFamily="34" charset="-120"/>
               </a:rPr>
-              <a:t>Q2 — met, with one qualification</a:t>
-            </a:r>
-            <a:endParaRPr lang="en-US" sz="1600" dirty="0"/>
+              <a:t>My RQ1 and RQ3: met</a:t>
+            </a:r>
+            <a:endParaRPr lang="en-US" sz="1500" dirty="0"/>
           </a:p>
         </p:txBody>
       </p:sp>
@@ -4343,24 +4430,24 @@
         </p:nvSpPr>
         <p:spPr>
           <a:xfrm>
-            <a:off x="1554480" y="3703320"/>
-            <a:ext cx="4480560" cy="640080"/>
-          </a:xfrm>
-          <a:prstGeom prst="rect">
-            <a:avLst/>
-          </a:prstGeom>
-          <a:noFill/>
-          <a:ln/>
-        </p:spPr>
-        <p:txBody>
-          <a:bodyPr wrap="square" lIns="0" tIns="0" rIns="0" bIns="0" rtlCol="0" anchor="ctr"/>
-          <a:lstStyle/>
-          <a:p>
-            <a:pPr indent="0" marL="0">
-              <a:buNone/>
-            </a:pPr>
-            <a:r>
-              <a:rPr lang="en-US" sz="1200" dirty="0">
+            <a:off x="1554480" y="3236976"/>
+            <a:ext cx="4480560" cy="548640"/>
+          </a:xfrm>
+          <a:prstGeom prst="rect">
+            <a:avLst/>
+          </a:prstGeom>
+          <a:noFill/>
+          <a:ln/>
+        </p:spPr>
+        <p:txBody>
+          <a:bodyPr wrap="square" lIns="0" tIns="0" rIns="0" bIns="0" rtlCol="0" anchor="ctr"/>
+          <a:lstStyle/>
+          <a:p>
+            <a:pPr indent="0" marL="0">
+              <a:buNone/>
+            </a:pPr>
+            <a:r>
+              <a:rPr lang="en-US" sz="1150" dirty="0">
                 <a:solidFill>
                   <a:srgbClr val="DDE4EA"/>
                 </a:solidFill>
@@ -4368,9 +4455,9 @@
                 <a:ea typeface="Calibri" pitchFamily="34" charset="-122"/>
                 <a:cs typeface="Calibri" pitchFamily="34" charset="-120"/>
               </a:rPr>
-              <a:t>the test measured is the surrogate the original authors specify, not an implemented tolerant tester</a:t>
-            </a:r>
-            <a:endParaRPr lang="en-US" sz="1200" dirty="0"/>
+              <a:t>the theoretical ordering does not match the practical one; the fallback mechanism's real cost is measured in full</a:t>
+            </a:r>
+            <a:endParaRPr lang="en-US" sz="1150" dirty="0"/>
           </a:p>
         </p:txBody>
       </p:sp>
@@ -4382,12 +4469,12 @@
         </p:nvSpPr>
         <p:spPr>
           <a:xfrm>
-            <a:off x="640080" y="4654296"/>
-            <a:ext cx="5577840" cy="1280160"/>
+            <a:off x="640080" y="3986784"/>
+            <a:ext cx="5577840" cy="1024128"/>
           </a:xfrm>
           <a:prstGeom prst="roundRect">
             <a:avLst>
-              <a:gd name="adj" fmla="val 5714"/>
+              <a:gd name="adj" fmla="val 7143"/>
             </a:avLst>
           </a:prstGeom>
           <a:solidFill>
@@ -4409,7 +4496,171 @@
         </p:nvSpPr>
         <p:spPr>
           <a:xfrm>
-            <a:off x="914400" y="5065776"/>
+            <a:off x="914400" y="4270248"/>
+            <a:ext cx="457200" cy="457200"/>
+          </a:xfrm>
+          <a:prstGeom prst="ellipse">
+            <a:avLst/>
+          </a:prstGeom>
+          <a:solidFill>
+            <a:srgbClr val="C8A24B"/>
+          </a:solidFill>
+          <a:ln/>
+        </p:spPr>
+      </p:sp>
+      <p:sp>
+        <p:nvSpPr>
+          <p:cNvPr id="17" name="Text 14"/>
+          <p:cNvSpPr/>
+          <p:nvPr/>
+        </p:nvSpPr>
+        <p:spPr>
+          <a:xfrm>
+            <a:off x="914400" y="4270248"/>
+            <a:ext cx="457200" cy="457200"/>
+          </a:xfrm>
+          <a:prstGeom prst="rect">
+            <a:avLst/>
+          </a:prstGeom>
+          <a:noFill/>
+          <a:ln/>
+        </p:spPr>
+        <p:txBody>
+          <a:bodyPr wrap="square" lIns="0" tIns="0" rIns="0" bIns="0" rtlCol="0" anchor="ctr"/>
+          <a:lstStyle/>
+          <a:p>
+            <a:pPr algn="ctr" indent="0" marL="0">
+              <a:buNone/>
+            </a:pPr>
+            <a:r>
+              <a:rPr lang="en-US" sz="1500" b="1" dirty="0">
+                <a:solidFill>
+                  <a:srgbClr val="FFFFFF"/>
+                </a:solidFill>
+                <a:latin typeface="Calibri" pitchFamily="34" charset="0"/>
+                <a:ea typeface="Calibri" pitchFamily="34" charset="-122"/>
+                <a:cs typeface="Calibri" pitchFamily="34" charset="-120"/>
+              </a:rPr>
+              <a:t>3</a:t>
+            </a:r>
+            <a:endParaRPr lang="en-US" sz="1500" dirty="0"/>
+          </a:p>
+        </p:txBody>
+      </p:sp>
+      <p:sp>
+        <p:nvSpPr>
+          <p:cNvPr id="18" name="Text 15"/>
+          <p:cNvSpPr/>
+          <p:nvPr/>
+        </p:nvSpPr>
+        <p:spPr>
+          <a:xfrm>
+            <a:off x="1554480" y="4096512"/>
+            <a:ext cx="4480560" cy="292608"/>
+          </a:xfrm>
+          <a:prstGeom prst="rect">
+            <a:avLst/>
+          </a:prstGeom>
+          <a:noFill/>
+          <a:ln/>
+        </p:spPr>
+        <p:txBody>
+          <a:bodyPr wrap="square" lIns="0" tIns="0" rIns="0" bIns="0" rtlCol="0" anchor="ctr"/>
+          <a:lstStyle/>
+          <a:p>
+            <a:pPr indent="0" marL="0">
+              <a:buNone/>
+            </a:pPr>
+            <a:r>
+              <a:rPr lang="en-US" sz="1500" b="1" dirty="0">
+                <a:solidFill>
+                  <a:srgbClr val="FFFFFF"/>
+                </a:solidFill>
+                <a:latin typeface="Cambria" pitchFamily="34" charset="0"/>
+                <a:ea typeface="Cambria" pitchFamily="34" charset="-122"/>
+                <a:cs typeface="Cambria" pitchFamily="34" charset="-120"/>
+              </a:rPr>
+              <a:t>RQ2: met in part</a:t>
+            </a:r>
+            <a:endParaRPr lang="en-US" sz="1500" dirty="0"/>
+          </a:p>
+        </p:txBody>
+      </p:sp>
+      <p:sp>
+        <p:nvSpPr>
+          <p:cNvPr id="19" name="Text 16"/>
+          <p:cNvSpPr/>
+          <p:nvPr/>
+        </p:nvSpPr>
+        <p:spPr>
+          <a:xfrm>
+            <a:off x="1554480" y="4407408"/>
+            <a:ext cx="4480560" cy="548640"/>
+          </a:xfrm>
+          <a:prstGeom prst="rect">
+            <a:avLst/>
+          </a:prstGeom>
+          <a:noFill/>
+          <a:ln/>
+        </p:spPr>
+        <p:txBody>
+          <a:bodyPr wrap="square" lIns="0" tIns="0" rIns="0" bIns="0" rtlCol="0" anchor="ctr"/>
+          <a:lstStyle/>
+          <a:p>
+            <a:pPr indent="0" marL="0">
+              <a:buNone/>
+            </a:pPr>
+            <a:r>
+              <a:rPr lang="en-US" sz="1150" dirty="0">
+                <a:solidFill>
+                  <a:srgbClr val="DDE4EA"/>
+                </a:solidFill>
+                <a:latin typeface="Calibri" pitchFamily="34" charset="0"/>
+                <a:ea typeface="Calibri" pitchFamily="34" charset="-122"/>
+                <a:cs typeface="Calibri" pitchFamily="34" charset="-120"/>
+              </a:rPr>
+              <a:t>the order-error curve is stronger than I asked for; where algorithms' curves cross is answered only qualitatively</a:t>
+            </a:r>
+            <a:endParaRPr lang="en-US" sz="1150" dirty="0"/>
+          </a:p>
+        </p:txBody>
+      </p:sp>
+      <p:sp>
+        <p:nvSpPr>
+          <p:cNvPr id="20" name="Shape 17"/>
+          <p:cNvSpPr/>
+          <p:nvPr/>
+        </p:nvSpPr>
+        <p:spPr>
+          <a:xfrm>
+            <a:off x="640080" y="5157216"/>
+            <a:ext cx="5577840" cy="1024128"/>
+          </a:xfrm>
+          <a:prstGeom prst="roundRect">
+            <a:avLst>
+              <a:gd name="adj" fmla="val 7143"/>
+            </a:avLst>
+          </a:prstGeom>
+          <a:solidFill>
+            <a:srgbClr val="2E3A46"/>
+          </a:solidFill>
+          <a:ln w="12700">
+            <a:solidFill>
+              <a:srgbClr val="2E3A46"/>
+            </a:solidFill>
+            <a:prstDash val="solid"/>
+          </a:ln>
+        </p:spPr>
+      </p:sp>
+      <p:sp>
+        <p:nvSpPr>
+          <p:cNvPr id="21" name="Shape 18"/>
+          <p:cNvSpPr/>
+          <p:nvPr/>
+        </p:nvSpPr>
+        <p:spPr>
+          <a:xfrm>
+            <a:off x="914400" y="5440680"/>
             <a:ext cx="457200" cy="457200"/>
           </a:xfrm>
           <a:prstGeom prst="ellipse">
@@ -4423,13 +4674,13 @@
       </p:sp>
       <p:sp>
         <p:nvSpPr>
-          <p:cNvPr id="17" name="Text 14"/>
-          <p:cNvSpPr/>
-          <p:nvPr/>
-        </p:nvSpPr>
-        <p:spPr>
-          <a:xfrm>
-            <a:off x="914400" y="5065776"/>
+          <p:cNvPr id="22" name="Text 19"/>
+          <p:cNvSpPr/>
+          <p:nvPr/>
+        </p:nvSpPr>
+        <p:spPr>
+          <a:xfrm>
+            <a:off x="914400" y="5440680"/>
             <a:ext cx="457200" cy="457200"/>
           </a:xfrm>
           <a:prstGeom prst="rect">
@@ -4454,7 +4705,7 @@
                 <a:ea typeface="Calibri" pitchFamily="34" charset="-122"/>
                 <a:cs typeface="Calibri" pitchFamily="34" charset="-120"/>
               </a:rPr>
-              <a:t>3</a:t>
+              <a:t>4</a:t>
             </a:r>
             <a:endParaRPr lang="en-US" sz="1500" dirty="0"/>
           </a:p>
@@ -4462,30 +4713,30 @@
       </p:sp>
       <p:sp>
         <p:nvSpPr>
-          <p:cNvPr id="18" name="Text 15"/>
-          <p:cNvSpPr/>
-          <p:nvPr/>
-        </p:nvSpPr>
-        <p:spPr>
-          <a:xfrm>
-            <a:off x="1554480" y="4818888"/>
-            <a:ext cx="4480560" cy="320040"/>
-          </a:xfrm>
-          <a:prstGeom prst="rect">
-            <a:avLst/>
-          </a:prstGeom>
-          <a:noFill/>
-          <a:ln/>
-        </p:spPr>
-        <p:txBody>
-          <a:bodyPr wrap="square" lIns="0" tIns="0" rIns="0" bIns="0" rtlCol="0" anchor="ctr"/>
-          <a:lstStyle/>
-          <a:p>
-            <a:pPr indent="0" marL="0">
-              <a:buNone/>
-            </a:pPr>
-            <a:r>
-              <a:rPr lang="en-US" sz="1600" b="1" dirty="0">
+          <p:cNvPr id="23" name="Text 20"/>
+          <p:cNvSpPr/>
+          <p:nvPr/>
+        </p:nvSpPr>
+        <p:spPr>
+          <a:xfrm>
+            <a:off x="1554480" y="5266944"/>
+            <a:ext cx="4480560" cy="292608"/>
+          </a:xfrm>
+          <a:prstGeom prst="rect">
+            <a:avLst/>
+          </a:prstGeom>
+          <a:noFill/>
+          <a:ln/>
+        </p:spPr>
+        <p:txBody>
+          <a:bodyPr wrap="square" lIns="0" tIns="0" rIns="0" bIns="0" rtlCol="0" anchor="ctr"/>
+          <a:lstStyle/>
+          <a:p>
+            <a:pPr indent="0" marL="0">
+              <a:buNone/>
+            </a:pPr>
+            <a:r>
+              <a:rPr lang="en-US" sz="1500" b="1" dirty="0">
                 <a:solidFill>
                   <a:srgbClr val="FFFFFF"/>
                 </a:solidFill>
@@ -4493,38 +4744,38 @@
                 <a:ea typeface="Cambria" pitchFamily="34" charset="-122"/>
                 <a:cs typeface="Cambria" pitchFamily="34" charset="-120"/>
               </a:rPr>
-              <a:t>Q3 — bracketed, not closed</a:t>
-            </a:r>
-            <a:endParaRPr lang="en-US" sz="1600" dirty="0"/>
-          </a:p>
-        </p:txBody>
-      </p:sp>
-      <p:sp>
-        <p:nvSpPr>
-          <p:cNvPr id="19" name="Text 16"/>
-          <p:cNvSpPr/>
-          <p:nvPr/>
-        </p:nvSpPr>
-        <p:spPr>
-          <a:xfrm>
-            <a:off x="1554480" y="5184648"/>
-            <a:ext cx="4480560" cy="640080"/>
-          </a:xfrm>
-          <a:prstGeom prst="rect">
-            <a:avLst/>
-          </a:prstGeom>
-          <a:noFill/>
-          <a:ln/>
-        </p:spPr>
-        <p:txBody>
-          <a:bodyPr wrap="square" lIns="0" tIns="0" rIns="0" bIns="0" rtlCol="0" anchor="ctr"/>
-          <a:lstStyle/>
-          <a:p>
-            <a:pPr indent="0" marL="0">
-              <a:buNone/>
-            </a:pPr>
-            <a:r>
-              <a:rPr lang="en-US" sz="1200" dirty="0">
+              <a:t>Not delivered: the adversarial arm</a:t>
+            </a:r>
+            <a:endParaRPr lang="en-US" sz="1500" dirty="0"/>
+          </a:p>
+        </p:txBody>
+      </p:sp>
+      <p:sp>
+        <p:nvSpPr>
+          <p:cNvPr id="24" name="Text 21"/>
+          <p:cNvSpPr/>
+          <p:nvPr/>
+        </p:nvSpPr>
+        <p:spPr>
+          <a:xfrm>
+            <a:off x="1554480" y="5577840"/>
+            <a:ext cx="4480560" cy="548640"/>
+          </a:xfrm>
+          <a:prstGeom prst="rect">
+            <a:avLst/>
+          </a:prstGeom>
+          <a:noFill/>
+          <a:ln/>
+        </p:spPr>
+        <p:txBody>
+          <a:bodyPr wrap="square" lIns="0" tIns="0" rIns="0" bIns="0" rtlCol="0" anchor="ctr"/>
+          <a:lstStyle/>
+          <a:p>
+            <a:pPr indent="0" marL="0">
+              <a:buNone/>
+            </a:pPr>
+            <a:r>
+              <a:rPr lang="en-US" sz="1150" dirty="0">
                 <a:solidFill>
                   <a:srgbClr val="DDE4EA"/>
                 </a:solidFill>
@@ -4532,21 +4783,21 @@
                 <a:ea typeface="Calibri" pitchFamily="34" charset="-122"/>
                 <a:cs typeface="Calibri" pitchFamily="34" charset="-120"/>
               </a:rPr>
-              <a:t>one proved inequality and a quantitative reading, not a theorem that the wall is forced</a:t>
-            </a:r>
-            <a:endParaRPr lang="en-US" sz="1200" dirty="0"/>
-          </a:p>
-        </p:txBody>
-      </p:sp>
-      <p:sp>
-        <p:nvSpPr>
-          <p:cNvPr id="20" name="Text 17"/>
-          <p:cNvSpPr/>
-          <p:nvPr/>
-        </p:nvSpPr>
-        <p:spPr>
-          <a:xfrm>
-            <a:off x="6858000" y="1691640"/>
+              <a:t>my proposal made arrival order an independent variable — I worked only in known-i.i.d., the model where my headline is most likely to hold</a:t>
+            </a:r>
+            <a:endParaRPr lang="en-US" sz="1150" dirty="0"/>
+          </a:p>
+        </p:txBody>
+      </p:sp>
+      <p:sp>
+        <p:nvSpPr>
+          <p:cNvPr id="25" name="Text 22"/>
+          <p:cNvSpPr/>
+          <p:nvPr/>
+        </p:nvSpPr>
+        <p:spPr>
+          <a:xfrm>
+            <a:off x="6858000" y="1645920"/>
             <a:ext cx="4572000" cy="365760"/>
           </a:xfrm>
           <a:prstGeom prst="rect">
@@ -4579,14 +4830,14 @@
       </p:sp>
       <p:sp>
         <p:nvSpPr>
-          <p:cNvPr id="21" name="Text 18"/>
-          <p:cNvSpPr/>
-          <p:nvPr/>
-        </p:nvSpPr>
-        <p:spPr>
-          <a:xfrm>
-            <a:off x="6858000" y="2240280"/>
-            <a:ext cx="4663440" cy="868680"/>
+          <p:cNvPr id="26" name="Text 23"/>
+          <p:cNvSpPr/>
+          <p:nvPr/>
+        </p:nvSpPr>
+        <p:spPr>
+          <a:xfrm>
+            <a:off x="6858000" y="2194560"/>
+            <a:ext cx="4663440" cy="896112"/>
           </a:xfrm>
           <a:prstGeom prst="rect">
             <a:avLst/>
@@ -4624,7 +4875,7 @@
                 <a:ea typeface="Calibri" pitchFamily="34" charset="-122"/>
                 <a:cs typeface="Calibri" pitchFamily="34" charset="-120"/>
               </a:rPr>
-              <a:t>structured error models — i.i.d. noise would have hidden the order effect entirely</a:t>
+              <a:t>structured error models — the proposal's own design bet, and i.i.d. noise would have hidden the order effect entirely</a:t>
             </a:r>
             <a:endParaRPr lang="en-US" sz="1250" dirty="0"/>
           </a:p>
@@ -4632,14 +4883,14 @@
       </p:sp>
       <p:sp>
         <p:nvSpPr>
-          <p:cNvPr id="22" name="Text 19"/>
-          <p:cNvSpPr/>
-          <p:nvPr/>
-        </p:nvSpPr>
-        <p:spPr>
-          <a:xfrm>
-            <a:off x="6858000" y="3246120"/>
-            <a:ext cx="4663440" cy="868680"/>
+          <p:cNvPr id="27" name="Text 24"/>
+          <p:cNvSpPr/>
+          <p:nvPr/>
+        </p:nvSpPr>
+        <p:spPr>
+          <a:xfrm>
+            <a:off x="6858000" y="3218688"/>
+            <a:ext cx="4663440" cy="896112"/>
           </a:xfrm>
           <a:prstGeom prst="rect">
             <a:avLst/>
@@ -4657,6 +4908,59 @@
             <a:r>
               <a:rPr lang="en-US" sz="1250" b="1" dirty="0">
                 <a:solidFill>
+                  <a:srgbClr val="2F6F6B"/>
+                </a:solidFill>
+                <a:latin typeface="Calibri" pitchFamily="34" charset="0"/>
+                <a:ea typeface="Calibri" pitchFamily="34" charset="-122"/>
+                <a:cs typeface="Calibri" pitchFamily="34" charset="-120"/>
+              </a:rPr>
+              <a:t>Right  </a:t>
+            </a:r>
+            <a:pPr indent="0" marL="0">
+              <a:buNone/>
+            </a:pPr>
+            <a:r>
+              <a:rPr lang="en-US" sz="1250" dirty="0">
+                <a:solidFill>
+                  <a:srgbClr val="DDE4EA"/>
+                </a:solidFill>
+                <a:latin typeface="Calibri" pitchFamily="34" charset="0"/>
+                <a:ea typeface="Calibri" pitchFamily="34" charset="-122"/>
+                <a:cs typeface="Calibri" pitchFamily="34" charset="-120"/>
+              </a:rPr>
+              <a:t>validating against Borodin et al. before building anything on the harness</a:t>
+            </a:r>
+            <a:endParaRPr lang="en-US" sz="1250" dirty="0"/>
+          </a:p>
+        </p:txBody>
+      </p:sp>
+      <p:sp>
+        <p:nvSpPr>
+          <p:cNvPr id="28" name="Text 25"/>
+          <p:cNvSpPr/>
+          <p:nvPr/>
+        </p:nvSpPr>
+        <p:spPr>
+          <a:xfrm>
+            <a:off x="6858000" y="4242816"/>
+            <a:ext cx="4663440" cy="896112"/>
+          </a:xfrm>
+          <a:prstGeom prst="rect">
+            <a:avLst/>
+          </a:prstGeom>
+          <a:noFill/>
+          <a:ln/>
+        </p:spPr>
+        <p:txBody>
+          <a:bodyPr wrap="square" lIns="0" tIns="0" rIns="0" bIns="0" rtlCol="0" anchor="t"/>
+          <a:lstStyle/>
+          <a:p>
+            <a:pPr indent="0" marL="0">
+              <a:buNone/>
+            </a:pPr>
+            <a:r>
+              <a:rPr lang="en-US" sz="1250" b="1" dirty="0">
+                <a:solidFill>
                   <a:srgbClr val="C8A24B"/>
                 </a:solidFill>
                 <a:latin typeface="Calibri" pitchFamily="34" charset="0"/>
@@ -4677,7 +4981,7 @@
                 <a:ea typeface="Calibri" pitchFamily="34" charset="-122"/>
                 <a:cs typeface="Calibri" pitchFamily="34" charset="-120"/>
               </a:rPr>
-              <a:t>known-i.i.d. is the model where the baseline is strongest, so the choice partly pre-selected the headline</a:t>
+              <a:t>measuring only matching size — a second objective should have run through the whole benchmark</a:t>
             </a:r>
             <a:endParaRPr lang="en-US" sz="1250" dirty="0"/>
           </a:p>
@@ -4685,67 +4989,14 @@
       </p:sp>
       <p:sp>
         <p:nvSpPr>
-          <p:cNvPr id="23" name="Text 20"/>
-          <p:cNvSpPr/>
-          <p:nvPr/>
-        </p:nvSpPr>
-        <p:spPr>
-          <a:xfrm>
-            <a:off x="6858000" y="4251960"/>
-            <a:ext cx="4663440" cy="868680"/>
-          </a:xfrm>
-          <a:prstGeom prst="rect">
-            <a:avLst/>
-          </a:prstGeom>
-          <a:noFill/>
-          <a:ln/>
-        </p:spPr>
-        <p:txBody>
-          <a:bodyPr wrap="square" lIns="0" tIns="0" rIns="0" bIns="0" rtlCol="0" anchor="t"/>
-          <a:lstStyle/>
-          <a:p>
-            <a:pPr indent="0" marL="0">
-              <a:buNone/>
-            </a:pPr>
-            <a:r>
-              <a:rPr lang="en-US" sz="1250" b="1" dirty="0">
-                <a:solidFill>
-                  <a:srgbClr val="C8A24B"/>
-                </a:solidFill>
-                <a:latin typeface="Calibri" pitchFamily="34" charset="0"/>
-                <a:ea typeface="Calibri" pitchFamily="34" charset="-122"/>
-                <a:cs typeface="Calibri" pitchFamily="34" charset="-120"/>
-              </a:rPr>
-              <a:t>Debatable  </a:t>
-            </a:r>
-            <a:pPr indent="0" marL="0">
-              <a:buNone/>
-            </a:pPr>
-            <a:r>
-              <a:rPr lang="en-US" sz="1250" dirty="0">
-                <a:solidFill>
-                  <a:srgbClr val="DDE4EA"/>
-                </a:solidFill>
-                <a:latin typeface="Calibri" pitchFamily="34" charset="0"/>
-                <a:ea typeface="Calibri" pitchFamily="34" charset="-122"/>
-                <a:cs typeface="Calibri" pitchFamily="34" charset="-120"/>
-              </a:rPr>
-              <a:t>measuring only matching size — a second objective should have run through the whole benchmark</a:t>
-            </a:r>
-            <a:endParaRPr lang="en-US" sz="1250" dirty="0"/>
-          </a:p>
-        </p:txBody>
-      </p:sp>
-      <p:sp>
-        <p:nvSpPr>
-          <p:cNvPr id="24" name="Text 21"/>
-          <p:cNvSpPr/>
-          <p:nvPr/>
-        </p:nvSpPr>
-        <p:spPr>
-          <a:xfrm>
-            <a:off x="6858000" y="5257800"/>
-            <a:ext cx="4663440" cy="868680"/>
+          <p:cNvPr id="29" name="Text 26"/>
+          <p:cNvSpPr/>
+          <p:nvPr/>
+        </p:nvSpPr>
+        <p:spPr>
+          <a:xfrm>
+            <a:off x="6858000" y="5266944"/>
+            <a:ext cx="4663440" cy="896112"/>
           </a:xfrm>
           <a:prstGeom prst="rect">
             <a:avLst/>
@@ -5921,6 +6172,338 @@
 <file path=ppt/slides/slide15.xml><?xml version="1.0" encoding="utf-8"?>
 <p:sld xmlns:a="http://schemas.openxmlformats.org/drawingml/2006/main" xmlns:r="http://schemas.openxmlformats.org/officeDocument/2006/relationships" xmlns:p="http://schemas.openxmlformats.org/presentationml/2006/main">
   <p:cSld name="Slide 15">
+    <p:bg>
+      <p:bgPr>
+        <a:solidFill>
+          <a:srgbClr val="FFFFFF"/>
+        </a:solidFill>
+      </p:bgPr>
+    </p:bg>
+    <p:spTree>
+      <p:nvGrpSpPr>
+        <p:cNvPr id="1" name=""/>
+        <p:cNvGrpSpPr/>
+        <p:nvPr/>
+      </p:nvGrpSpPr>
+      <p:grpSpPr>
+        <a:xfrm>
+          <a:off x="0" y="0"/>
+          <a:ext cx="0" cy="0"/>
+          <a:chOff x="0" y="0"/>
+          <a:chExt cx="0" cy="0"/>
+        </a:xfrm>
+      </p:grpSpPr>
+      <p:sp>
+        <p:nvSpPr>
+          <p:cNvPr id="3" name="Text 0"/>
+          <p:cNvSpPr/>
+          <p:nvPr/>
+        </p:nvSpPr>
+        <p:spPr>
+          <a:xfrm>
+            <a:off x="640080" y="384048"/>
+            <a:ext cx="9144000" cy="256032"/>
+          </a:xfrm>
+          <a:prstGeom prst="rect">
+            <a:avLst/>
+          </a:prstGeom>
+          <a:noFill/>
+          <a:ln/>
+        </p:spPr>
+        <p:txBody>
+          <a:bodyPr wrap="square" lIns="0" tIns="0" rIns="0" bIns="0" rtlCol="0" anchor="ctr"/>
+          <a:lstStyle/>
+          <a:p>
+            <a:pPr indent="0" marL="0">
+              <a:buNone/>
+            </a:pPr>
+            <a:r>
+              <a:rPr lang="en-US" sz="1100" b="1" spc="200" kern="0" dirty="0">
+                <a:solidFill>
+                  <a:srgbClr val="6B7280"/>
+                </a:solidFill>
+                <a:latin typeface="Calibri" pitchFamily="34" charset="0"/>
+                <a:ea typeface="Calibri" pitchFamily="34" charset="-122"/>
+                <a:cs typeface="Calibri" pitchFamily="34" charset="-120"/>
+              </a:rPr>
+              <a:t>FOR QUESTIONS · APPENDIX A.7</a:t>
+            </a:r>
+            <a:endParaRPr lang="en-US" sz="1100" dirty="0"/>
+          </a:p>
+        </p:txBody>
+      </p:sp>
+      <p:sp>
+        <p:nvSpPr>
+          <p:cNvPr id="4" name="Text 1"/>
+          <p:cNvSpPr/>
+          <p:nvPr/>
+        </p:nvSpPr>
+        <p:spPr>
+          <a:xfrm>
+            <a:off x="640080" y="658368"/>
+            <a:ext cx="10881360" cy="731520"/>
+          </a:xfrm>
+          <a:prstGeom prst="rect">
+            <a:avLst/>
+          </a:prstGeom>
+          <a:noFill/>
+          <a:ln/>
+        </p:spPr>
+        <p:txBody>
+          <a:bodyPr wrap="square" lIns="0" tIns="0" rIns="0" bIns="0" rtlCol="0" anchor="t"/>
+          <a:lstStyle/>
+          <a:p>
+            <a:pPr indent="0" marL="0">
+              <a:buNone/>
+            </a:pPr>
+            <a:r>
+              <a:rPr lang="en-US" sz="3200" b="1" dirty="0">
+                <a:solidFill>
+                  <a:srgbClr val="2B3440"/>
+                </a:solidFill>
+                <a:latin typeface="Cambria" pitchFamily="34" charset="0"/>
+                <a:ea typeface="Cambria" pitchFamily="34" charset="-122"/>
+                <a:cs typeface="Cambria" pitchFamily="34" charset="-120"/>
+              </a:rPr>
+              <a:t>Backup · the relaxation ladder</a:t>
+            </a:r>
+            <a:endParaRPr lang="en-US" sz="3200" dirty="0"/>
+          </a:p>
+        </p:txBody>
+      </p:sp>
+      <p:pic>
+        <p:nvPicPr>
+          <p:cNvPr id="5" name="Image 0" descr="/Users/lizhuolun/Desktop/TB-3/matching-experiments/results/streaming_ladder.png">    </p:cNvPr>
+          <p:cNvPicPr>
+            <a:picLocks noChangeAspect="1"/>
+          </p:cNvPicPr>
+          <p:nvPr/>
+        </p:nvPicPr>
+        <p:blipFill>
+          <a:blip r:embed="rId1"/>
+          <a:stretch>
+            <a:fillRect/>
+          </a:stretch>
+        </p:blipFill>
+        <p:spPr>
+          <a:xfrm>
+            <a:off x="2112721" y="1417320"/>
+            <a:ext cx="7936078" cy="3017520"/>
+          </a:xfrm>
+          <a:prstGeom prst="rect">
+            <a:avLst/>
+          </a:prstGeom>
+        </p:spPr>
+      </p:pic>
+      <p:sp>
+        <p:nvSpPr>
+          <p:cNvPr id="6" name="Text 2"/>
+          <p:cNvSpPr/>
+          <p:nvPr/>
+        </p:nvSpPr>
+        <p:spPr>
+          <a:xfrm>
+            <a:off x="640080" y="4526280"/>
+            <a:ext cx="10881360" cy="457200"/>
+          </a:xfrm>
+          <a:prstGeom prst="rect">
+            <a:avLst/>
+          </a:prstGeom>
+          <a:noFill/>
+          <a:ln/>
+        </p:spPr>
+        <p:txBody>
+          <a:bodyPr wrap="square" lIns="0" tIns="0" rIns="0" bIns="0" rtlCol="0" anchor="ctr"/>
+          <a:lstStyle/>
+          <a:p>
+            <a:pPr indent="0" marL="0">
+              <a:buNone/>
+            </a:pPr>
+            <a:r>
+              <a:rPr lang="en-US" sz="1300" dirty="0">
+                <a:solidFill>
+                  <a:srgbClr val="6B7280"/>
+                </a:solidFill>
+                <a:latin typeface="Calibri" pitchFamily="34" charset="0"/>
+                <a:ea typeface="Calibri" pitchFamily="34" charset="-122"/>
+                <a:cs typeface="Calibri" pitchFamily="34" charset="-120"/>
+              </a:rPr>
+              <a:t>The brief suggested streaming or offline algorithms. Placed as a ladder of relaxations of the same instance, they separate the online model's two constraints — bounded memory, and no revision.</a:t>
+            </a:r>
+            <a:endParaRPr lang="en-US" sz="1300" dirty="0"/>
+          </a:p>
+        </p:txBody>
+      </p:sp>
+      <p:sp>
+        <p:nvSpPr>
+          <p:cNvPr id="7" name="Text 3"/>
+          <p:cNvSpPr/>
+          <p:nvPr/>
+        </p:nvSpPr>
+        <p:spPr>
+          <a:xfrm>
+            <a:off x="640080" y="5074920"/>
+            <a:ext cx="10881360" cy="530352"/>
+          </a:xfrm>
+          <a:prstGeom prst="rect">
+            <a:avLst/>
+          </a:prstGeom>
+          <a:noFill/>
+          <a:ln/>
+        </p:spPr>
+        <p:txBody>
+          <a:bodyPr wrap="square" lIns="0" tIns="0" rIns="0" bIns="0" rtlCol="0" anchor="t"/>
+          <a:lstStyle/>
+          <a:p>
+            <a:pPr indent="0" marL="0">
+              <a:buNone/>
+            </a:pPr>
+            <a:r>
+              <a:rPr lang="en-US" sz="1200" b="1" dirty="0">
+                <a:solidFill>
+                  <a:srgbClr val="C1440E"/>
+                </a:solidFill>
+                <a:latin typeface="Calibri" pitchFamily="34" charset="0"/>
+                <a:ea typeface="Calibri" pitchFamily="34" charset="-122"/>
+                <a:cs typeface="Calibri" pitchFamily="34" charset="-120"/>
+              </a:rPr>
+              <a:t>One pass is not a free lunch — </a:t>
+            </a:r>
+            <a:pPr indent="0" marL="0">
+              <a:buNone/>
+            </a:pPr>
+            <a:r>
+              <a:rPr lang="en-US" sz="1200" dirty="0">
+                <a:solidFill>
+                  <a:srgbClr val="2B3440"/>
+                </a:solidFill>
+                <a:latin typeface="Calibri" pitchFamily="34" charset="0"/>
+                <a:ea typeface="Calibri" pitchFamily="34" charset="-122"/>
+                <a:cs typeface="Calibri" pitchFamily="34" charset="-120"/>
+              </a:rPr>
+              <a:t>edge arrival with O(n) memory is worse than online Greedy on seven of nine graphs — 0.879 against 0.964 on CE-PG. Both leave maximal matchings; grouping a node's edges together is what helps.</a:t>
+            </a:r>
+            <a:endParaRPr lang="en-US" sz="1200" dirty="0"/>
+          </a:p>
+        </p:txBody>
+      </p:sp>
+      <p:sp>
+        <p:nvSpPr>
+          <p:cNvPr id="8" name="Text 4"/>
+          <p:cNvSpPr/>
+          <p:nvPr/>
+        </p:nvSpPr>
+        <p:spPr>
+          <a:xfrm>
+            <a:off x="640080" y="5641848"/>
+            <a:ext cx="10881360" cy="530352"/>
+          </a:xfrm>
+          <a:prstGeom prst="rect">
+            <a:avLst/>
+          </a:prstGeom>
+          <a:noFill/>
+          <a:ln/>
+        </p:spPr>
+        <p:txBody>
+          <a:bodyPr wrap="square" lIns="0" tIns="0" rIns="0" bIns="0" rtlCol="0" anchor="t"/>
+          <a:lstStyle/>
+          <a:p>
+            <a:pPr indent="0" marL="0">
+              <a:buNone/>
+            </a:pPr>
+            <a:r>
+              <a:rPr lang="en-US" sz="1200" b="1" dirty="0">
+                <a:solidFill>
+                  <a:srgbClr val="2F6F6B"/>
+                </a:solidFill>
+                <a:latin typeface="Calibri" pitchFamily="34" charset="0"/>
+                <a:ea typeface="Calibri" pitchFamily="34" charset="-122"/>
+                <a:cs typeface="Calibri" pitchFamily="34" charset="-120"/>
+              </a:rPr>
+              <a:t>The second pass is the lever — </a:t>
+            </a:r>
+            <a:pPr indent="0" marL="0">
+              <a:buNone/>
+            </a:pPr>
+            <a:r>
+              <a:rPr lang="en-US" sz="1200" dirty="0">
+                <a:solidFill>
+                  <a:srgbClr val="2B3440"/>
+                </a:solidFill>
+                <a:latin typeface="Calibri" pitchFamily="34" charset="0"/>
+                <a:ea typeface="Calibri" pitchFamily="34" charset="-122"/>
+                <a:cs typeface="Calibri" pitchFamily="34" charset="-120"/>
+              </a:rPr>
+              <a:t>one revision pass beats a perfect degree prediction on seven of nine, including all six real graphs (CE-PG +0.079 against +0.033).</a:t>
+            </a:r>
+            <a:endParaRPr lang="en-US" sz="1200" dirty="0"/>
+          </a:p>
+        </p:txBody>
+      </p:sp>
+      <p:sp>
+        <p:nvSpPr>
+          <p:cNvPr id="9" name="Text 5"/>
+          <p:cNvSpPr/>
+          <p:nvPr/>
+        </p:nvSpPr>
+        <p:spPr>
+          <a:xfrm>
+            <a:off x="640080" y="6208776"/>
+            <a:ext cx="10881360" cy="530352"/>
+          </a:xfrm>
+          <a:prstGeom prst="rect">
+            <a:avLst/>
+          </a:prstGeom>
+          <a:noFill/>
+          <a:ln/>
+        </p:spPr>
+        <p:txBody>
+          <a:bodyPr wrap="square" lIns="0" tIns="0" rIns="0" bIns="0" rtlCol="0" anchor="t"/>
+          <a:lstStyle/>
+          <a:p>
+            <a:pPr indent="0" marL="0">
+              <a:buNone/>
+            </a:pPr>
+            <a:r>
+              <a:rPr lang="en-US" sz="1200" b="1" dirty="0">
+                <a:solidFill>
+                  <a:srgbClr val="C8A24B"/>
+                </a:solidFill>
+                <a:latin typeface="Calibri" pitchFamily="34" charset="0"/>
+                <a:ea typeface="Calibri" pitchFamily="34" charset="-122"/>
+                <a:cs typeface="Calibri" pitchFamily="34" charset="-120"/>
+              </a:rPr>
+              <a:t>So the residual gap is irrevocability — </a:t>
+            </a:r>
+            <a:pPr indent="0" marL="0">
+              <a:buNone/>
+            </a:pPr>
+            <a:r>
+              <a:rPr lang="en-US" sz="1200" dirty="0">
+                <a:solidFill>
+                  <a:srgbClr val="2B3440"/>
+                </a:solidFill>
+                <a:latin typeface="Calibri" pitchFamily="34" charset="0"/>
+                <a:ea typeface="Calibri" pitchFamily="34" charset="-122"/>
+                <a:cs typeface="Calibri" pitchFamily="34" charset="-120"/>
+              </a:rPr>
+              <a:t>not missing information. But a second pass is not an online algorithm — where decisions are physically committed, prediction is the only route.</a:t>
+            </a:r>
+            <a:endParaRPr lang="en-US" sz="1200" dirty="0"/>
+          </a:p>
+        </p:txBody>
+      </p:sp>
+    </p:spTree>
+  </p:cSld>
+  <p:clrMapOvr>
+    <a:masterClrMapping/>
+  </p:clrMapOvr>
+</p:sld>
+</file>
+
+<file path=ppt/slides/slide16.xml><?xml version="1.0" encoding="utf-8"?>
+<p:sld xmlns:a="http://schemas.openxmlformats.org/drawingml/2006/main" xmlns:r="http://schemas.openxmlformats.org/officeDocument/2006/relationships" xmlns:p="http://schemas.openxmlformats.org/presentationml/2006/main">
+  <p:cSld name="Slide 16">
     <p:bg>
       <p:bgPr>
         <a:solidFill>

</xml_diff>